<commit_message>
Use FHFA's quarterly U.S. index and the seasonally adjusted index for changes since 2019 Q4
</commit_message>
<xml_diff>
--- a/briefings/housing-market-briefing.pptx
+++ b/briefings/housing-market-briefing.pptx
@@ -136,7 +136,7 @@
               <c:strCache>
                 <c:ptCount val="1"/>
                 <c:pt idx="0">
-                  <c:v>U.S. HPI</c:v>
+                  <c:v>U.S. HPI, seasonally adjusted</c:v>
                 </c:pt>
               </c:strCache>
             </c:strRef>
@@ -175,7 +175,7 @@
                           <a:srgbClr val="B1BAC4"/>
                         </a:solidFill>
                       </a:rPr>
-                      <a:t>275.0</a:t>
+                      <a:t>271.5</a:t>
                     </a:r>
                   </a:p>
                 </c:rich>
@@ -211,7 +211,7 @@
                           <a:srgbClr val="F0F6FC"/>
                         </a:solidFill>
                       </a:rPr>
-                      <a:t>450.9</a:t>
+                      <a:t>435.7</a:t>
                     </a:r>
                   </a:p>
                 </c:rich>
@@ -673,430 +673,430 @@
                 <c:formatCode>General</c:formatCode>
                 <c:ptCount val="142"/>
                 <c:pt idx="0">
-                  <c:v>100.3</c:v>
+                  <c:v>100.0</c:v>
                 </c:pt>
                 <c:pt idx="1">
+                  <c:v>100.0</c:v>
+                </c:pt>
+                <c:pt idx="2">
+                  <c:v>100.2</c:v>
+                </c:pt>
+                <c:pt idx="3">
                   <c:v>101.0</c:v>
                 </c:pt>
-                <c:pt idx="2">
-                  <c:v>101.3</c:v>
-                </c:pt>
-                <c:pt idx="3">
-                  <c:v>101.9</c:v>
-                </c:pt>
                 <c:pt idx="4">
-                  <c:v>102.7</c:v>
+                  <c:v>102.3</c:v>
                 </c:pt>
                 <c:pt idx="5">
-                  <c:v>103.1</c:v>
+                  <c:v>102.1</c:v>
                 </c:pt>
                 <c:pt idx="6">
-                  <c:v>104.1</c:v>
+                  <c:v>103.0</c:v>
                 </c:pt>
                 <c:pt idx="7">
-                  <c:v>104.7</c:v>
+                  <c:v>103.8</c:v>
                 </c:pt>
                 <c:pt idx="8">
-                  <c:v>104.2</c:v>
+                  <c:v>103.8</c:v>
                 </c:pt>
                 <c:pt idx="9">
-                  <c:v>105.9</c:v>
+                  <c:v>104.8</c:v>
                 </c:pt>
                 <c:pt idx="10">
-                  <c:v>106.9</c:v>
+                  <c:v>105.6</c:v>
                 </c:pt>
                 <c:pt idx="11">
-                  <c:v>107.5</c:v>
+                  <c:v>106.7</c:v>
                 </c:pt>
                 <c:pt idx="12">
-                  <c:v>108.0</c:v>
+                  <c:v>107.6</c:v>
                 </c:pt>
                 <c:pt idx="13">
-                  <c:v>109.6</c:v>
+                  <c:v>108.5</c:v>
                 </c:pt>
                 <c:pt idx="14">
-                  <c:v>110.5</c:v>
+                  <c:v>109.1</c:v>
                 </c:pt>
                 <c:pt idx="15">
-                  <c:v>110.6</c:v>
+                  <c:v>109.7</c:v>
                 </c:pt>
                 <c:pt idx="16">
-                  <c:v>110.8</c:v>
+                  <c:v>110.3</c:v>
                 </c:pt>
                 <c:pt idx="17">
-                  <c:v>112.2</c:v>
+                  <c:v>111.0</c:v>
                 </c:pt>
                 <c:pt idx="18">
-                  <c:v>113.5</c:v>
+                  <c:v>112.0</c:v>
                 </c:pt>
                 <c:pt idx="19">
+                  <c:v>112.7</c:v>
+                </c:pt>
+                <c:pt idx="20">
                   <c:v>113.6</c:v>
                 </c:pt>
-                <c:pt idx="20">
-                  <c:v>114.1</c:v>
-                </c:pt>
                 <c:pt idx="21">
+                  <c:v>114.4</c:v>
+                </c:pt>
+                <c:pt idx="22">
+                  <c:v>115.1</c:v>
+                </c:pt>
+                <c:pt idx="23">
                   <c:v>115.8</c:v>
                 </c:pt>
-                <c:pt idx="22">
-                  <c:v>116.7</c:v>
-                </c:pt>
-                <c:pt idx="23">
-                  <c:v>116.7</c:v>
-                </c:pt>
                 <c:pt idx="24">
-                  <c:v>117.0</c:v>
+                  <c:v>116.5</c:v>
                 </c:pt>
                 <c:pt idx="25">
-                  <c:v>118.9</c:v>
+                  <c:v>117.5</c:v>
                 </c:pt>
                 <c:pt idx="26">
-                  <c:v>120.0</c:v>
+                  <c:v>118.3</c:v>
                 </c:pt>
                 <c:pt idx="27">
-                  <c:v>120.5</c:v>
+                  <c:v>119.6</c:v>
                 </c:pt>
                 <c:pt idx="28">
-                  <c:v>121.6</c:v>
+                  <c:v>121.1</c:v>
                 </c:pt>
                 <c:pt idx="29">
+                  <c:v>122.7</c:v>
+                </c:pt>
+                <c:pt idx="30">
                   <c:v>124.3</c:v>
                 </c:pt>
-                <c:pt idx="30">
-                  <c:v>126.2</c:v>
-                </c:pt>
                 <c:pt idx="31">
-                  <c:v>127.4</c:v>
+                  <c:v>126.4</c:v>
                 </c:pt>
                 <c:pt idx="32">
-                  <c:v>128.8</c:v>
+                  <c:v>128.2</c:v>
                 </c:pt>
                 <c:pt idx="33">
-                  <c:v>131.8</c:v>
+                  <c:v>130.1</c:v>
                 </c:pt>
                 <c:pt idx="34">
+                  <c:v>132.1</c:v>
+                </c:pt>
+                <c:pt idx="35">
                   <c:v>134.1</c:v>
                 </c:pt>
-                <c:pt idx="35">
-                  <c:v>135.1</c:v>
-                </c:pt>
                 <c:pt idx="36">
-                  <c:v>137.1</c:v>
+                  <c:v>136.4</c:v>
                 </c:pt>
                 <c:pt idx="37">
-                  <c:v>140.6</c:v>
+                  <c:v>138.7</c:v>
                 </c:pt>
                 <c:pt idx="38">
-                  <c:v>143.1</c:v>
+                  <c:v>140.9</c:v>
                 </c:pt>
                 <c:pt idx="39">
-                  <c:v>144.6</c:v>
+                  <c:v>143.4</c:v>
                 </c:pt>
                 <c:pt idx="40">
-                  <c:v>146.7</c:v>
+                  <c:v>146.0</c:v>
                 </c:pt>
                 <c:pt idx="41">
-                  <c:v>150.4</c:v>
+                  <c:v>148.4</c:v>
                 </c:pt>
                 <c:pt idx="42">
-                  <c:v>153.1</c:v>
+                  <c:v>150.6</c:v>
                 </c:pt>
                 <c:pt idx="43">
-                  <c:v>154.3</c:v>
+                  <c:v>153.0</c:v>
                 </c:pt>
                 <c:pt idx="44">
-                  <c:v>156.3</c:v>
+                  <c:v>155.5</c:v>
                 </c:pt>
                 <c:pt idx="45">
-                  <c:v>160.6</c:v>
+                  <c:v>158.4</c:v>
                 </c:pt>
                 <c:pt idx="46">
-                  <c:v>164.1</c:v>
+                  <c:v>161.4</c:v>
                 </c:pt>
                 <c:pt idx="47">
-                  <c:v>166.1</c:v>
+                  <c:v>164.6</c:v>
                 </c:pt>
                 <c:pt idx="48">
-                  <c:v>168.3</c:v>
+                  <c:v>167.5</c:v>
                 </c:pt>
                 <c:pt idx="49">
-                  <c:v>172.6</c:v>
+                  <c:v>170.2</c:v>
                 </c:pt>
                 <c:pt idx="50">
-                  <c:v>176.6</c:v>
+                  <c:v>173.6</c:v>
                 </c:pt>
                 <c:pt idx="51">
-                  <c:v>179.0</c:v>
+                  <c:v>177.4</c:v>
                 </c:pt>
                 <c:pt idx="52">
-                  <c:v>182.0</c:v>
+                  <c:v>181.4</c:v>
                 </c:pt>
                 <c:pt idx="53">
+                  <c:v>186.0</c:v>
+                </c:pt>
+                <c:pt idx="54">
+                  <c:v>190.8</c:v>
+                </c:pt>
+                <c:pt idx="55">
+                  <c:v>195.4</c:v>
+                </c:pt>
+                <c:pt idx="56">
+                  <c:v>200.3</c:v>
+                </c:pt>
+                <c:pt idx="57">
+                  <c:v>205.6</c:v>
+                </c:pt>
+                <c:pt idx="58">
+                  <c:v>211.0</c:v>
+                </c:pt>
+                <c:pt idx="59">
+                  <c:v>215.5</c:v>
+                </c:pt>
+                <c:pt idx="60">
+                  <c:v>218.7</c:v>
+                </c:pt>
+                <c:pt idx="61">
+                  <c:v>220.2</c:v>
+                </c:pt>
+                <c:pt idx="62">
+                  <c:v>220.5</c:v>
+                </c:pt>
+                <c:pt idx="63">
+                  <c:v>221.5</c:v>
+                </c:pt>
+                <c:pt idx="64">
+                  <c:v>222.8</c:v>
+                </c:pt>
+                <c:pt idx="65">
+                  <c:v>222.2</c:v>
+                </c:pt>
+                <c:pt idx="66">
+                  <c:v>219.3</c:v>
+                </c:pt>
+                <c:pt idx="67">
+                  <c:v>215.3</c:v>
+                </c:pt>
+                <c:pt idx="68">
+                  <c:v>210.4</c:v>
+                </c:pt>
+                <c:pt idx="69">
+                  <c:v>204.5</c:v>
+                </c:pt>
+                <c:pt idx="70">
+                  <c:v>199.3</c:v>
+                </c:pt>
+                <c:pt idx="71">
+                  <c:v>193.5</c:v>
+                </c:pt>
+                <c:pt idx="72">
+                  <c:v>192.2</c:v>
+                </c:pt>
+                <c:pt idx="73">
+                  <c:v>189.6</c:v>
+                </c:pt>
+                <c:pt idx="74">
                   <c:v>188.7</c:v>
                 </c:pt>
-                <c:pt idx="54">
-                  <c:v>194.1</c:v>
-                </c:pt>
-                <c:pt idx="55">
-                  <c:v>197.1</c:v>
-                </c:pt>
-                <c:pt idx="56">
-                  <c:v>200.8</c:v>
-                </c:pt>
-                <c:pt idx="57">
-                  <c:v>208.6</c:v>
-                </c:pt>
-                <c:pt idx="58">
-                  <c:v>214.7</c:v>
-                </c:pt>
-                <c:pt idx="59">
-                  <c:v>217.1</c:v>
-                </c:pt>
-                <c:pt idx="60">
-                  <c:v>219.2</c:v>
-                </c:pt>
-                <c:pt idx="61">
-                  <c:v>223.5</c:v>
-                </c:pt>
-                <c:pt idx="62">
-                  <c:v>224.4</c:v>
-                </c:pt>
-                <c:pt idx="63">
-                  <c:v>223.1</c:v>
-                </c:pt>
-                <c:pt idx="64">
-                  <c:v>223.2</c:v>
-                </c:pt>
-                <c:pt idx="65">
-                  <c:v>225.9</c:v>
-                </c:pt>
-                <c:pt idx="66">
-                  <c:v>223.3</c:v>
-                </c:pt>
-                <c:pt idx="67">
-                  <c:v>216.9</c:v>
-                </c:pt>
-                <c:pt idx="68">
-                  <c:v>210.9</c:v>
-                </c:pt>
-                <c:pt idx="69">
-                  <c:v>208.1</c:v>
-                </c:pt>
-                <c:pt idx="70">
-                  <c:v>203.0</c:v>
-                </c:pt>
-                <c:pt idx="71">
-                  <c:v>194.7</c:v>
-                </c:pt>
-                <c:pt idx="72">
-                  <c:v>192.6</c:v>
-                </c:pt>
-                <c:pt idx="73">
-                  <c:v>193.2</c:v>
-                </c:pt>
-                <c:pt idx="74">
-                  <c:v>192.7</c:v>
-                </c:pt>
                 <c:pt idx="75">
-                  <c:v>190.4</c:v>
+                  <c:v>188.6</c:v>
                 </c:pt>
                 <c:pt idx="76">
-                  <c:v>187.1</c:v>
+                  <c:v>186.9</c:v>
                 </c:pt>
                 <c:pt idx="77">
-                  <c:v>189.9</c:v>
+                  <c:v>185.9</c:v>
                 </c:pt>
                 <c:pt idx="78">
-                  <c:v>187.2</c:v>
+                  <c:v>182.9</c:v>
                 </c:pt>
                 <c:pt idx="79">
-                  <c:v>183.1</c:v>
+                  <c:v>181.1</c:v>
                 </c:pt>
                 <c:pt idx="80">
-                  <c:v>177.3</c:v>
+                  <c:v>177.0</c:v>
                 </c:pt>
                 <c:pt idx="81">
-                  <c:v>179.5</c:v>
+                  <c:v>175.5</c:v>
                 </c:pt>
                 <c:pt idx="82">
-                  <c:v>180.6</c:v>
+                  <c:v>176.0</c:v>
                 </c:pt>
                 <c:pt idx="83">
-                  <c:v>178.3</c:v>
+                  <c:v>176.3</c:v>
                 </c:pt>
                 <c:pt idx="84">
                   <c:v>177.1</c:v>
                 </c:pt>
                 <c:pt idx="85">
-                  <c:v>184.2</c:v>
+                  <c:v>179.9</c:v>
                 </c:pt>
                 <c:pt idx="86">
-                  <c:v>187.0</c:v>
+                  <c:v>182.0</c:v>
                 </c:pt>
                 <c:pt idx="87">
-                  <c:v>186.9</c:v>
+                  <c:v>184.8</c:v>
                 </c:pt>
                 <c:pt idx="88">
-                  <c:v>188.8</c:v>
+                  <c:v>188.6</c:v>
                 </c:pt>
                 <c:pt idx="89">
-                  <c:v>197.2</c:v>
+                  <c:v>192.3</c:v>
                 </c:pt>
                 <c:pt idx="90">
-                  <c:v>200.7</c:v>
+                  <c:v>195.3</c:v>
                 </c:pt>
                 <c:pt idx="91">
-                  <c:v>199.5</c:v>
+                  <c:v>197.3</c:v>
                 </c:pt>
                 <c:pt idx="92">
-                  <c:v>200.1</c:v>
+                  <c:v>199.7</c:v>
                 </c:pt>
                 <c:pt idx="93">
-                  <c:v>206.7</c:v>
+                  <c:v>201.4</c:v>
                 </c:pt>
                 <c:pt idx="94">
-                  <c:v>209.2</c:v>
+                  <c:v>203.6</c:v>
                 </c:pt>
                 <c:pt idx="95">
-                  <c:v>208.5</c:v>
+                  <c:v>206.2</c:v>
                 </c:pt>
                 <c:pt idx="96">
-                  <c:v>209.8</c:v>
+                  <c:v>209.0</c:v>
                 </c:pt>
                 <c:pt idx="97">
-                  <c:v>217.4</c:v>
+                  <c:v>211.7</c:v>
                 </c:pt>
                 <c:pt idx="98">
-                  <c:v>220.1</c:v>
+                  <c:v>214.2</c:v>
                 </c:pt>
                 <c:pt idx="99">
-                  <c:v>219.8</c:v>
+                  <c:v>217.3</c:v>
                 </c:pt>
                 <c:pt idx="100">
-                  <c:v>221.2</c:v>
+                  <c:v>219.9</c:v>
                 </c:pt>
                 <c:pt idx="101">
-                  <c:v>229.2</c:v>
+                  <c:v>223.1</c:v>
                 </c:pt>
                 <c:pt idx="102">
-                  <c:v>232.6</c:v>
+                  <c:v>226.4</c:v>
                 </c:pt>
                 <c:pt idx="103">
-                  <c:v>232.7</c:v>
+                  <c:v>229.9</c:v>
                 </c:pt>
                 <c:pt idx="104">
-                  <c:v>234.6</c:v>
+                  <c:v>232.9</c:v>
                 </c:pt>
                 <c:pt idx="105">
-                  <c:v>243.4</c:v>
+                  <c:v>236.9</c:v>
                 </c:pt>
                 <c:pt idx="106">
-                  <c:v>246.9</c:v>
+                  <c:v>240.4</c:v>
                 </c:pt>
                 <c:pt idx="107">
-                  <c:v>247.1</c:v>
+                  <c:v>244.1</c:v>
                 </c:pt>
                 <c:pt idx="108">
-                  <c:v>250.9</c:v>
+                  <c:v>248.6</c:v>
                 </c:pt>
                 <c:pt idx="109">
-                  <c:v>258.5</c:v>
+                  <c:v>251.4</c:v>
                 </c:pt>
                 <c:pt idx="110">
-                  <c:v>261.4</c:v>
+                  <c:v>254.6</c:v>
                 </c:pt>
                 <c:pt idx="111">
-                  <c:v>260.6</c:v>
+                  <c:v>257.4</c:v>
                 </c:pt>
                 <c:pt idx="112">
-                  <c:v>263.2</c:v>
+                  <c:v>260.5</c:v>
                 </c:pt>
                 <c:pt idx="113">
-                  <c:v>271.3</c:v>
+                  <c:v>263.5</c:v>
                 </c:pt>
                 <c:pt idx="114">
-                  <c:v>274.1</c:v>
+                  <c:v>267.0</c:v>
                 </c:pt>
                 <c:pt idx="115">
-                  <c:v>275.0</c:v>
+                  <c:v>271.5</c:v>
                 </c:pt>
                 <c:pt idx="116">
-                  <c:v>279.6</c:v>
+                  <c:v>276.7</c:v>
                 </c:pt>
                 <c:pt idx="117">
-                  <c:v>286.6</c:v>
+                  <c:v>278.3</c:v>
                 </c:pt>
                 <c:pt idx="118">
-                  <c:v>296.6</c:v>
+                  <c:v>288.8</c:v>
                 </c:pt>
                 <c:pt idx="119">
-                  <c:v>305.5</c:v>
+                  <c:v>301.7</c:v>
                 </c:pt>
                 <c:pt idx="120">
-                  <c:v>316.0</c:v>
+                  <c:v>312.5</c:v>
                 </c:pt>
                 <c:pt idx="121">
-                  <c:v>336.8</c:v>
+                  <c:v>326.6</c:v>
                 </c:pt>
                 <c:pt idx="122">
-                  <c:v>350.4</c:v>
+                  <c:v>341.2</c:v>
                 </c:pt>
                 <c:pt idx="123">
-                  <c:v>358.3</c:v>
+                  <c:v>354.1</c:v>
                 </c:pt>
                 <c:pt idx="124">
-                  <c:v>373.3</c:v>
+                  <c:v>369.1</c:v>
                 </c:pt>
                 <c:pt idx="125">
-                  <c:v>393.3</c:v>
+                  <c:v>380.8</c:v>
                 </c:pt>
                 <c:pt idx="126">
-                  <c:v>390.5</c:v>
+                  <c:v>380.4</c:v>
                 </c:pt>
                 <c:pt idx="127">
-                  <c:v>385.3</c:v>
+                  <c:v>381.3</c:v>
                 </c:pt>
                 <c:pt idx="128">
-                  <c:v>388.6</c:v>
+                  <c:v>384.2</c:v>
                 </c:pt>
                 <c:pt idx="129">
-                  <c:v>404.4</c:v>
+                  <c:v>391.5</c:v>
                 </c:pt>
                 <c:pt idx="130">
-                  <c:v>410.5</c:v>
+                  <c:v>400.0</c:v>
                 </c:pt>
                 <c:pt idx="131">
-                  <c:v>409.4</c:v>
+                  <c:v>404.6</c:v>
                 </c:pt>
                 <c:pt idx="132">
-                  <c:v>414.1</c:v>
+                  <c:v>408.9</c:v>
                 </c:pt>
                 <c:pt idx="133">
-                  <c:v>427.8</c:v>
+                  <c:v>413.8</c:v>
                 </c:pt>
                 <c:pt idx="134">
-                  <c:v>429.1</c:v>
+                  <c:v>417.8</c:v>
                 </c:pt>
                 <c:pt idx="135">
-                  <c:v>428.8</c:v>
+                  <c:v>423.1</c:v>
                 </c:pt>
                 <c:pt idx="136">
-                  <c:v>432.6</c:v>
+                  <c:v>426.2</c:v>
                 </c:pt>
                 <c:pt idx="137">
-                  <c:v>441.0</c:v>
+                  <c:v>426.6</c:v>
                 </c:pt>
                 <c:pt idx="138">
-                  <c:v>439.5</c:v>
+                  <c:v>428.1</c:v>
                 </c:pt>
                 <c:pt idx="139">
-                  <c:v>437.9</c:v>
+                  <c:v>431.7</c:v>
                 </c:pt>
                 <c:pt idx="140">
-                  <c:v>441.2</c:v>
+                  <c:v>434.2</c:v>
                 </c:pt>
                 <c:pt idx="141">
-                  <c:v>450.9</c:v>
+                  <c:v>435.7</c:v>
                 </c:pt>
               </c:numCache>
             </c:numRef>
@@ -1334,7 +1334,7 @@
                           <a:srgbClr val="F0F6FC"/>
                         </a:solidFill>
                       </a:rPr>
-                      <a:t>18.2%</a:t>
+                      <a:t>18.1%</a:t>
                     </a:r>
                   </a:p>
                 </c:rich>
@@ -1360,7 +1360,7 @@
                           <a:srgbClr val="F0F6FC"/>
                         </a:solidFill>
                       </a:rPr>
-                      <a:t>2.3%</a:t>
+                      <a:t>2.1%</a:t>
                     </a:r>
                   </a:p>
                 </c:rich>
@@ -1498,16 +1498,16 @@
                 <c:formatCode>General</c:formatCode>
                 <c:ptCount val="34"/>
                 <c:pt idx="0">
-                  <c:v>6.9</c:v>
+                  <c:v>6.8</c:v>
                 </c:pt>
                 <c:pt idx="1">
-                  <c:v>6.2</c:v>
+                  <c:v>6.1</c:v>
                 </c:pt>
                 <c:pt idx="2">
-                  <c:v>5.9</c:v>
+                  <c:v>5.8</c:v>
                 </c:pt>
                 <c:pt idx="3">
-                  <c:v>5.5</c:v>
+                  <c:v>5.4</c:v>
                 </c:pt>
                 <c:pt idx="4">
                   <c:v>4.9</c:v>
@@ -1516,22 +1516,22 @@
                   <c:v>4.9</c:v>
                 </c:pt>
                 <c:pt idx="6">
-                  <c:v>4.9</c:v>
+                  <c:v>4.8</c:v>
                 </c:pt>
                 <c:pt idx="7">
-                  <c:v>5.5</c:v>
+                  <c:v>5.4</c:v>
                 </c:pt>
                 <c:pt idx="8">
                   <c:v>6.2</c:v>
                 </c:pt>
                 <c:pt idx="9">
-                  <c:v>5.6</c:v>
+                  <c:v>5.7</c:v>
                 </c:pt>
                 <c:pt idx="10">
-                  <c:v>8.2</c:v>
+                  <c:v>8.1</c:v>
                 </c:pt>
                 <c:pt idx="11">
-                  <c:v>11.1</c:v>
+                  <c:v>11.0</c:v>
                 </c:pt>
                 <c:pt idx="12">
                   <c:v>13.0</c:v>
@@ -1540,7 +1540,7 @@
                   <c:v>17.5</c:v>
                 </c:pt>
                 <c:pt idx="14">
-                  <c:v>18.2</c:v>
+                  <c:v>18.1</c:v>
                 </c:pt>
                 <c:pt idx="15">
                   <c:v>17.3</c:v>
@@ -1549,13 +1549,13 @@
                   <c:v>18.1</c:v>
                 </c:pt>
                 <c:pt idx="17">
-                  <c:v>16.8</c:v>
+                  <c:v>16.7</c:v>
                 </c:pt>
                 <c:pt idx="18">
-                  <c:v>11.4</c:v>
+                  <c:v>11.5</c:v>
                 </c:pt>
                 <c:pt idx="19">
-                  <c:v>7.5</c:v>
+                  <c:v>7.6</c:v>
                 </c:pt>
                 <c:pt idx="20">
                   <c:v>4.1</c:v>
@@ -1567,25 +1567,25 @@
                   <c:v>5.1</c:v>
                 </c:pt>
                 <c:pt idx="23">
-                  <c:v>6.3</c:v>
+                  <c:v>6.1</c:v>
                 </c:pt>
                 <c:pt idx="24">
-                  <c:v>6.6</c:v>
+                  <c:v>6.5</c:v>
                 </c:pt>
                 <c:pt idx="25">
-                  <c:v>5.8</c:v>
+                  <c:v>5.7</c:v>
                 </c:pt>
                 <c:pt idx="26">
-                  <c:v>4.5</c:v>
+                  <c:v>4.4</c:v>
                 </c:pt>
                 <c:pt idx="27">
-                  <c:v>4.7</c:v>
+                  <c:v>4.6</c:v>
                 </c:pt>
                 <c:pt idx="28">
-                  <c:v>4.5</c:v>
+                  <c:v>4.3</c:v>
                 </c:pt>
                 <c:pt idx="29">
-                  <c:v>3.1</c:v>
+                  <c:v>3.0</c:v>
                 </c:pt>
                 <c:pt idx="30">
                   <c:v>2.4</c:v>
@@ -1594,10 +1594,10 @@
                   <c:v>2.1</c:v>
                 </c:pt>
                 <c:pt idx="32">
-                  <c:v>2.0</c:v>
+                  <c:v>1.9</c:v>
                 </c:pt>
                 <c:pt idx="33">
-                  <c:v>2.3</c:v>
+                  <c:v>2.1</c:v>
                 </c:pt>
               </c:numCache>
             </c:numRef>
@@ -3022,7 +3022,7 @@
           <a:lstStyle/>
           <a:p>
             <a:r>
-              <a:t>This briefing uses public FHFA house price index data through 2026 Q2 and CFPB HMDA mortgage data for 2018 to 2025. The U.S. index is 450.9, where 1991 Q1 equals 100. The index shows price change, not dollar prices. Prices are 64.0% above 2019 Q4, the last quarter before the pandemic. Compared with 2025 Q2, they rose 2.3%. Each U.S. quarterly value is the average of the three monthly values.</a:t>
+              <a:t>This briefing uses public FHFA house price index data through 2026 Q2 and CFPB HMDA mortgage data for 2018 to 2025. The U.S. index is 435.7, where 1991 Q1 equals 100. The index shows price change, not dollar prices. Prices are 60.5% above 2019 Q4, the last quarter before the pandemic. Compared with 2025 Q2, they rose 2.1%. The U.S. values come from FHFA's quarterly U.S. index. The index level and the change since 2019 Q4 are seasonally adjusted, because they compare different seasons. The year-over-year change is not seasonally adjusted.</a:t>
             </a:r>
           </a:p>
         </p:txBody>
@@ -3073,7 +3073,7 @@
           <a:lstStyle/>
           <a:p>
             <a:r>
-              <a:t>The line shows the U.S. purchase-only house price index since 1991. In 2019 Q4 the index was 275.0. In 2026 Q2 it is 450.9, an increase of 64.0%. The steepest climb was from 2020 to 2022. Since then the line continues to go up, but more slowly. This is an index of price change, not an average dollar price.</a:t>
+              <a:t>The line shows the U.S. purchase-only house price index since 1991. In 2019 Q4 the seasonally adjusted index was 271.5. In 2026 Q2 it is 435.7, an increase of 60.5%. The steepest climb was from 2020 to 2022. Since then the line continues to go up, but more slowly. This is an index of price change, not an average dollar price.</a:t>
             </a:r>
           </a:p>
         </p:txBody>
@@ -3124,7 +3124,7 @@
           <a:lstStyle/>
           <a:p>
             <a:r>
-              <a:t>Each bar shows how much U.S. prices changed compared with the same quarter one year earlier. Growth peaked at 18.2% in 2021 Q3. In 2026 Q2 it is 2.3%. The two orange bars mark the peak and the latest quarter. At the national level prices did not fall; the rate of increase became smaller.</a:t>
+              <a:t>Each bar shows how much U.S. prices changed compared with the same quarter one year earlier. Growth peaked at 18.1% in 2021 Q3. In 2026 Q2 it is 2.1%. The two orange bars mark the peak and the latest quarter. At the national level prices did not fall; the rate of increase became smaller.</a:t>
             </a:r>
           </a:p>
         </p:txBody>
@@ -3328,7 +3328,7 @@
           <a:lstStyle/>
           <a:p>
             <a:r>
-              <a:t>First, U.S. prices are 64.0% above 2019 Q4 and rose 2.3% in the last year. Second, the change is uneven: 4 states and 26 of the 100 largest metros show a decrease, while Alaska rose 8.3%. Third, refinance and cash-out refinance originations in 2025 were 78% below the 2020 peak, and home purchase originations were 18% below 2018. These are facts from the data, not forecasts.</a:t>
+              <a:t>First, U.S. prices are 60.5% above 2019 Q4 and rose 2.1% in the last year. Second, the change is uneven: 4 states and 26 of the 100 largest metros show a decrease, while Alaska rose 8.3%. Third, refinance and cash-out refinance originations in 2025 were 78% below the 2020 peak, and home purchase originations were 18% below 2018. These are facts from the data, not forecasts.</a:t>
             </a:r>
           </a:p>
         </p:txBody>
@@ -3914,7 +3914,7 @@
                 </a:solidFill>
                 <a:latin typeface="Arial"/>
               </a:rPr>
-              <a:t>U.S. home prices are 64% above 2019 Q4, but annual growth has slowed to 2.3%</a:t>
+              <a:t>U.S. home prices are 60% above 2019 Q4, but annual growth has slowed to 2.1%</a:t>
             </a:r>
           </a:p>
         </p:txBody>
@@ -4072,7 +4072,7 @@
                 </a:solidFill>
                 <a:latin typeface="Arial"/>
               </a:rPr>
-              <a:t>450.9</a:t>
+              <a:t>435.7</a:t>
             </a:r>
           </a:p>
         </p:txBody>
@@ -4138,7 +4138,7 @@
                 </a:solidFill>
                 <a:latin typeface="Arial"/>
               </a:rPr>
-              <a:t>2026 Q2, 1991 Q1 = 100</a:t>
+              <a:t>2026 Q2, seasonally adjusted</a:t>
             </a:r>
           </a:p>
         </p:txBody>
@@ -4263,7 +4263,7 @@
                 </a:solidFill>
                 <a:latin typeface="Arial"/>
               </a:rPr>
-              <a:t>+2.3%</a:t>
+              <a:t>+2.1%</a:t>
             </a:r>
           </a:p>
         </p:txBody>
@@ -4454,7 +4454,7 @@
                 </a:solidFill>
                 <a:latin typeface="Arial"/>
               </a:rPr>
-              <a:t>+64.0%</a:t>
+              <a:t>+60.5%</a:t>
             </a:r>
           </a:p>
         </p:txBody>
@@ -4553,7 +4553,7 @@
                 </a:solidFill>
                 <a:latin typeface="Arial"/>
               </a:rPr>
-              <a:t>Source: FHFA House Price Index, purchase-only, not seasonally adjusted (1991 Q1 = 100). Latest period: 2026 Q2.</a:t>
+              <a:t>Source: FHFA HPI, purchase-only (1991 Q1 = 100), 2026 Q2. YoY: not seasonally adjusted. Levels and since 2019 Q4: seasonally adjusted.</a:t>
             </a:r>
           </a:p>
         </p:txBody>
@@ -4750,7 +4750,7 @@
                 </a:solidFill>
                 <a:latin typeface="Arial"/>
               </a:rPr>
-              <a:t>The U.S. price index is at a record high, 64% above its pre-pandemic level</a:t>
+              <a:t>The U.S. price index is at a record high, 60% above its pre-pandemic level</a:t>
             </a:r>
           </a:p>
         </p:txBody>
@@ -4816,7 +4816,7 @@
                 </a:solidFill>
                 <a:latin typeface="Arial"/>
               </a:rPr>
-              <a:t>Source: FHFA House Price Index, purchase-only, not seasonally adjusted (1991 Q1 = 100). Latest period: 2026 Q2.</a:t>
+              <a:t>Source: FHFA HPI, purchase-only (1991 Q1 = 100), 2026 Q2. YoY: not seasonally adjusted. Levels and since 2019 Q4: seasonally adjusted.</a:t>
             </a:r>
           </a:p>
         </p:txBody>
@@ -4930,7 +4930,7 @@
                 </a:solidFill>
                 <a:latin typeface="Arial"/>
               </a:rPr>
-              <a:t>U.S. house price index (1991 Q1 = 100), quarterly</a:t>
+              <a:t>U.S. house price index (1991 Q1 = 100), quarterly, seasonally adjusted</a:t>
             </a:r>
           </a:p>
         </p:txBody>
@@ -5145,7 +5145,7 @@
                 </a:solidFill>
                 <a:latin typeface="Arial"/>
               </a:rPr>
-              <a:t>Annual price growth fell from 18.2% in 2021 Q3 to 2.3% in 2026 Q2</a:t>
+              <a:t>Annual price growth fell from 18.1% in 2021 Q3 to 2.1% in 2026 Q2</a:t>
             </a:r>
           </a:p>
         </p:txBody>
@@ -5211,7 +5211,7 @@
                 </a:solidFill>
                 <a:latin typeface="Arial"/>
               </a:rPr>
-              <a:t>Source: FHFA House Price Index, purchase-only, not seasonally adjusted (1991 Q1 = 100). Latest period: 2026 Q2.</a:t>
+              <a:t>Source: FHFA HPI, purchase-only (1991 Q1 = 100), 2026 Q2. YoY: not seasonally adjusted. Levels and since 2019 Q4: seasonally adjusted.</a:t>
             </a:r>
           </a:p>
         </p:txBody>
@@ -5573,7 +5573,7 @@
                 </a:solidFill>
                 <a:latin typeface="Arial"/>
               </a:rPr>
-              <a:t>Five fastest and five slowest of 50 states and DC. U.S.: +2.3%. Blue = increase, orange = decrease.</a:t>
+              <a:t>Five fastest and five slowest of 50 states and DC. U.S.: +2.1%. Blue = increase, orange = decrease.</a:t>
             </a:r>
           </a:p>
         </p:txBody>
@@ -5606,7 +5606,7 @@
                 </a:solidFill>
                 <a:latin typeface="Arial"/>
               </a:rPr>
-              <a:t>Source: FHFA House Price Index, purchase-only, not seasonally adjusted (1991 Q1 = 100). Latest period: 2026 Q2.</a:t>
+              <a:t>Source: FHFA HPI, purchase-only (1991 Q1 = 100), 2026 Q2. YoY: not seasonally adjusted. Levels and since 2019 Q4: seasonally adjusted.</a:t>
             </a:r>
           </a:p>
         </p:txBody>
@@ -6001,7 +6001,7 @@
                 </a:solidFill>
                 <a:latin typeface="Arial"/>
               </a:rPr>
-              <a:t>Source: FHFA House Price Index, purchase-only, not seasonally adjusted (1991 Q1 = 100). Latest period: 2026 Q2.</a:t>
+              <a:t>Source: FHFA HPI, purchase-only (1991 Q1 = 100), 2026 Q2. YoY: not seasonally adjusted. Levels and since 2019 Q4: seasonally adjusted.</a:t>
             </a:r>
           </a:p>
         </p:txBody>
@@ -7059,7 +7059,7 @@
                 </a:solidFill>
                 <a:latin typeface="Arial"/>
               </a:rPr>
-              <a:t>+64%</a:t>
+              <a:t>+60%</a:t>
             </a:r>
           </a:p>
         </p:txBody>
@@ -7092,7 +7092,7 @@
                 </a:solidFill>
                 <a:latin typeface="Arial"/>
               </a:rPr>
-              <a:t>U.S. index change since 2019 Q4. Growth slowed to +2.3% year over year in 2026 Q2.</a:t>
+              <a:t>U.S. index change since 2019 Q4. Growth slowed to +2.1% year over year in 2026 Q2.</a:t>
             </a:r>
           </a:p>
         </p:txBody>

</xml_diff>